<commit_message>
deck 4: split wave 4 and 5 into separate timeline columns; accuracy pass on attributions and unsourced claims
Co-authored-by: arena-agent <297053741+arena-agent@users.noreply.github.com>
</commit_message>
<xml_diff>
--- a/Group-Mentoring-Presentation.pptx
+++ b/Group-Mentoring-Presentation.pptx
@@ -32114,7 +32114,7 @@
                 <a:cs typeface="IRANSans"/>
                 <a:ea typeface="IRANSans"/>
               </a:rPr>
-              <a:t>۹۰٪ روی کلاس و دوره</a:t>
+              <a:t>عمدتاً روی کلاس و دوره</a:t>
             </a:r>
           </a:p>
         </p:txBody>
@@ -32172,7 +32172,7 @@
                 <a:cs typeface="IRANSans"/>
                 <a:ea typeface="IRANSans"/>
               </a:rPr>
-              <a:t>۹۰٪</a:t>
+              <a:t>بخش عمده بودجه</a:t>
             </a:r>
             <a:r>
               <a:rPr sz="1550" b="0">
@@ -32183,7 +32183,7 @@
                 <a:cs typeface="IRANSans"/>
                 <a:ea typeface="IRANSans"/>
               </a:rPr>
-              <a:t> بودجه، روی </a:t>
+              <a:t>، روی </a:t>
             </a:r>
             <a:r>
               <a:rPr sz="1550" b="1">

</xml_diff>